<commit_message>
Write project narrative from the team's perspective
</commit_message>
<xml_diff>
--- a/DropCRM_Presentation_2026.pptx
+++ b/DropCRM_Presentation_2026.pptx
@@ -2,20 +2,20 @@
 <file path=ppt/presentation.xml><?xml version="1.0" encoding="utf-8"?>
 <p:presentation xmlns:p="http://schemas.openxmlformats.org/presentationml/2006/main">
   <p:sldMasterIdLst>
-    <p:sldMasterId xmlns:r="http://schemas.openxmlformats.org/officeDocument/2006/relationships" id="2147483648" r:id="Re7929f02e6a141b1"/>
+    <p:sldMasterId xmlns:r="http://schemas.openxmlformats.org/officeDocument/2006/relationships" id="2147483648" r:id="Raa38183e3f3f4bc5"/>
   </p:sldMasterIdLst>
   <p:notesMasterIdLst>
-    <p:notesMasterId xmlns:r="http://schemas.openxmlformats.org/officeDocument/2006/relationships" r:id="Rff93caa9e9f54965"/>
+    <p:notesMasterId xmlns:r="http://schemas.openxmlformats.org/officeDocument/2006/relationships" r:id="R7d733101c4094fbd"/>
   </p:notesMasterIdLst>
   <p:sldIdLst>
-    <p:sldId xmlns:r="http://schemas.openxmlformats.org/officeDocument/2006/relationships" id="256" r:id="Rc54f584e9a834870"/>
-    <p:sldId xmlns:r="http://schemas.openxmlformats.org/officeDocument/2006/relationships" id="257" r:id="R172e4bbab29d4498"/>
-    <p:sldId xmlns:r="http://schemas.openxmlformats.org/officeDocument/2006/relationships" id="258" r:id="R9430c9f5917c4a30"/>
-    <p:sldId xmlns:r="http://schemas.openxmlformats.org/officeDocument/2006/relationships" id="259" r:id="R8cb1d8723f8a478a"/>
-    <p:sldId xmlns:r="http://schemas.openxmlformats.org/officeDocument/2006/relationships" id="260" r:id="Rfee287a60739460e"/>
-    <p:sldId xmlns:r="http://schemas.openxmlformats.org/officeDocument/2006/relationships" id="261" r:id="R4ae637120dee427a"/>
-    <p:sldId xmlns:r="http://schemas.openxmlformats.org/officeDocument/2006/relationships" id="262" r:id="Rcaccf518b06a4a8a"/>
-    <p:sldId xmlns:r="http://schemas.openxmlformats.org/officeDocument/2006/relationships" id="263" r:id="R5e8d7a12362445ae"/>
+    <p:sldId xmlns:r="http://schemas.openxmlformats.org/officeDocument/2006/relationships" id="256" r:id="R5e7e3bd0387e46dc"/>
+    <p:sldId xmlns:r="http://schemas.openxmlformats.org/officeDocument/2006/relationships" id="257" r:id="R8a3f18ba5eb446e4"/>
+    <p:sldId xmlns:r="http://schemas.openxmlformats.org/officeDocument/2006/relationships" id="258" r:id="R8e20d828676f4799"/>
+    <p:sldId xmlns:r="http://schemas.openxmlformats.org/officeDocument/2006/relationships" id="259" r:id="R5649f96009ef4caa"/>
+    <p:sldId xmlns:r="http://schemas.openxmlformats.org/officeDocument/2006/relationships" id="260" r:id="R005d5408f7f94a60"/>
+    <p:sldId xmlns:r="http://schemas.openxmlformats.org/officeDocument/2006/relationships" id="261" r:id="Rae09e82c441743f2"/>
+    <p:sldId xmlns:r="http://schemas.openxmlformats.org/officeDocument/2006/relationships" id="262" r:id="Rcc40be183a49466d"/>
+    <p:sldId xmlns:r="http://schemas.openxmlformats.org/officeDocument/2006/relationships" id="263" r:id="Re826346a6ff54e09"/>
   </p:sldIdLst>
   <p:sldSz cx="12192000" cy="6858000"/>
   <p:notesSz cx="6858000" cy="9144000"/>
@@ -869,7 +869,7 @@
           <a:lstStyle xmlns:a="http://schemas.openxmlformats.org/drawingml/2006/main"/>
           <a:p xmlns:a="http://schemas.openxmlformats.org/drawingml/2006/main">
             <a:r>
-              <a:t>Это качественное наблюдение автора за двумя родственниками. Формальные задачи, время и цитаты не фиксировались. Источник: docs/usability-testing.md; методика NN/g https://www.nngroup.com/articles/usability-testing-101/.</a:t>
+              <a:t>Олег показал прототип своим родителям. Мы рассматриваем это как качественное наблюдение; формальные задачи, время и цитаты не фиксировались. Источник: docs/usability-testing.md; методика NN/g https://www.nngroup.com/articles/usability-testing-101/.</a:t>
             </a:r>
           </a:p>
         </p:txBody>
@@ -986,7 +986,7 @@
           <p:cNvPr id="3" name="Title">
             <a:extLst xmlns:a="http://schemas.openxmlformats.org/drawingml/2006/main">
               <a:ext uri="{FF2B5EF4-FFF2-40B4-BE49-F238E27FC236}">
-                <a16:creationId xmlns:a16="http://schemas.microsoft.com/office/drawing/2014/main" id="{291A5254-21BC-48B6-9FEA-2C65DDD0F313}"/>
+                <a16:creationId xmlns:a16="http://schemas.microsoft.com/office/drawing/2014/main" id="{23C88B14-9A6D-48B9-B54F-C7CBAF988A90}"/>
               </a:ext>
             </a:extLst>
           </p:cNvPr>
@@ -1215,7 +1215,7 @@
           <p:cNvPr id="2" name="Subtitle">
             <a:extLst xmlns:a="http://schemas.openxmlformats.org/drawingml/2006/main">
               <a:ext uri="{FF2B5EF4-FFF2-40B4-BE49-F238E27FC236}">
-                <a16:creationId xmlns:a16="http://schemas.microsoft.com/office/drawing/2014/main" id="{E98FF2AC-D856-4E1B-8ABB-62B6D69BF79B}"/>
+                <a16:creationId xmlns:a16="http://schemas.microsoft.com/office/drawing/2014/main" id="{853A0191-4593-4B51-81F4-85910FAB2E8D}"/>
               </a:ext>
             </a:extLst>
           </p:cNvPr>
@@ -1461,7 +1461,7 @@
           <p:cNvPr id="2" name="Section title">
             <a:extLst xmlns:a="http://schemas.openxmlformats.org/drawingml/2006/main">
               <a:ext uri="{FF2B5EF4-FFF2-40B4-BE49-F238E27FC236}">
-                <a16:creationId xmlns:a16="http://schemas.microsoft.com/office/drawing/2014/main" id="{4134ACAD-5A08-4F86-8FFC-DDF1989F884C}"/>
+                <a16:creationId xmlns:a16="http://schemas.microsoft.com/office/drawing/2014/main" id="{F430AC53-3008-4E50-9E5A-61DAD11C1160}"/>
               </a:ext>
             </a:extLst>
           </p:cNvPr>
@@ -1707,7 +1707,7 @@
           <p:cNvPr id="3" name="Title">
             <a:extLst xmlns:a="http://schemas.openxmlformats.org/drawingml/2006/main">
               <a:ext uri="{FF2B5EF4-FFF2-40B4-BE49-F238E27FC236}">
-                <a16:creationId xmlns:a16="http://schemas.microsoft.com/office/drawing/2014/main" id="{7143EDC9-E328-4CD9-AEAF-600D6447CA91}"/>
+                <a16:creationId xmlns:a16="http://schemas.microsoft.com/office/drawing/2014/main" id="{46F3A91E-76D6-41E1-AD70-8702E5340026}"/>
               </a:ext>
             </a:extLst>
           </p:cNvPr>
@@ -1936,7 +1936,7 @@
           <p:cNvPr id="2" name="Body">
             <a:extLst xmlns:a="http://schemas.openxmlformats.org/drawingml/2006/main">
               <a:ext uri="{FF2B5EF4-FFF2-40B4-BE49-F238E27FC236}">
-                <a16:creationId xmlns:a16="http://schemas.microsoft.com/office/drawing/2014/main" id="{E5F36864-C797-44ED-8ED5-2A370E583B32}"/>
+                <a16:creationId xmlns:a16="http://schemas.microsoft.com/office/drawing/2014/main" id="{4EED96EA-EB64-4656-8392-D18313F16877}"/>
               </a:ext>
             </a:extLst>
           </p:cNvPr>
@@ -2182,7 +2182,7 @@
           <p:cNvPr id="4" name="Title">
             <a:extLst xmlns:a="http://schemas.openxmlformats.org/drawingml/2006/main">
               <a:ext uri="{FF2B5EF4-FFF2-40B4-BE49-F238E27FC236}">
-                <a16:creationId xmlns:a16="http://schemas.microsoft.com/office/drawing/2014/main" id="{FBD1B78C-D05E-4758-82F7-005587FE8C80}"/>
+                <a16:creationId xmlns:a16="http://schemas.microsoft.com/office/drawing/2014/main" id="{45CD49E1-5654-4882-B342-88C42259A759}"/>
               </a:ext>
             </a:extLst>
           </p:cNvPr>
@@ -2411,7 +2411,7 @@
           <p:cNvPr id="2" name="Left column">
             <a:extLst xmlns:a="http://schemas.openxmlformats.org/drawingml/2006/main">
               <a:ext uri="{FF2B5EF4-FFF2-40B4-BE49-F238E27FC236}">
-                <a16:creationId xmlns:a16="http://schemas.microsoft.com/office/drawing/2014/main" id="{0CFAB1B5-D045-4965-BC75-BC09F2DCF981}"/>
+                <a16:creationId xmlns:a16="http://schemas.microsoft.com/office/drawing/2014/main" id="{AD7A0648-80F0-4639-9067-C045005237F5}"/>
               </a:ext>
             </a:extLst>
           </p:cNvPr>
@@ -2640,7 +2640,7 @@
           <p:cNvPr id="3" name="Right column">
             <a:extLst xmlns:a="http://schemas.openxmlformats.org/drawingml/2006/main">
               <a:ext uri="{FF2B5EF4-FFF2-40B4-BE49-F238E27FC236}">
-                <a16:creationId xmlns:a16="http://schemas.microsoft.com/office/drawing/2014/main" id="{4385A7A6-A90C-4D26-B2EC-7CF842CDD12F}"/>
+                <a16:creationId xmlns:a16="http://schemas.microsoft.com/office/drawing/2014/main" id="{CBCDF59D-6261-4313-A2B2-A0D54E6F1D1F}"/>
               </a:ext>
             </a:extLst>
           </p:cNvPr>
@@ -2886,7 +2886,7 @@
           <p:cNvPr id="3" name="Title">
             <a:extLst xmlns:a="http://schemas.openxmlformats.org/drawingml/2006/main">
               <a:ext uri="{FF2B5EF4-FFF2-40B4-BE49-F238E27FC236}">
-                <a16:creationId xmlns:a16="http://schemas.microsoft.com/office/drawing/2014/main" id="{9AEEA3A3-9E48-4E8D-A7FA-957E954392E2}"/>
+                <a16:creationId xmlns:a16="http://schemas.microsoft.com/office/drawing/2014/main" id="{6EFF3469-2CE1-4C59-8481-B353EF6ADECC}"/>
               </a:ext>
             </a:extLst>
           </p:cNvPr>
@@ -3115,7 +3115,7 @@
           <p:cNvPr id="2" name="Left column">
             <a:extLst xmlns:a="http://schemas.openxmlformats.org/drawingml/2006/main">
               <a:ext uri="{FF2B5EF4-FFF2-40B4-BE49-F238E27FC236}">
-                <a16:creationId xmlns:a16="http://schemas.microsoft.com/office/drawing/2014/main" id="{E59EFEE2-0A1A-4E92-90F7-541B50B2E728}"/>
+                <a16:creationId xmlns:a16="http://schemas.microsoft.com/office/drawing/2014/main" id="{F8A16CC6-89C8-4418-90B7-AF3BCF02E348}"/>
               </a:ext>
             </a:extLst>
           </p:cNvPr>
@@ -3382,12 +3382,12 @@
   </p:cSld>
   <p:clrMap bg1="lt1" tx1="dk1" bg2="lt2" tx2="dk2" accent1="accent1" accent2="accent2" accent3="accent3" accent4="accent4" accent5="accent5" accent6="accent6" hlink="hlink" folHlink="folHlink"/>
   <p:sldLayoutIdLst>
-    <p:sldLayoutId xmlns:r="http://schemas.openxmlformats.org/officeDocument/2006/relationships" id="2147483649" r:id="R88148289915e42bf"/>
-    <p:sldLayoutId xmlns:r="http://schemas.openxmlformats.org/officeDocument/2006/relationships" id="2147483650" r:id="Rbf021a65b99d47f7"/>
-    <p:sldLayoutId xmlns:r="http://schemas.openxmlformats.org/officeDocument/2006/relationships" id="2147483651" r:id="Rc412c4b6701a4231"/>
-    <p:sldLayoutId xmlns:r="http://schemas.openxmlformats.org/officeDocument/2006/relationships" id="2147483652" r:id="Rccc3bbf3c72f4fee"/>
-    <p:sldLayoutId xmlns:r="http://schemas.openxmlformats.org/officeDocument/2006/relationships" id="2147483653" r:id="Rf9cdbfbc80eb41bc"/>
-    <p:sldLayoutId xmlns:r="http://schemas.openxmlformats.org/officeDocument/2006/relationships" id="2147483654" r:id="R49a730a99f28416d"/>
+    <p:sldLayoutId xmlns:r="http://schemas.openxmlformats.org/officeDocument/2006/relationships" id="2147483649" r:id="Rf892dd3c24f742fc"/>
+    <p:sldLayoutId xmlns:r="http://schemas.openxmlformats.org/officeDocument/2006/relationships" id="2147483650" r:id="Rd755849c29c14c34"/>
+    <p:sldLayoutId xmlns:r="http://schemas.openxmlformats.org/officeDocument/2006/relationships" id="2147483651" r:id="R7c8b26189b374df0"/>
+    <p:sldLayoutId xmlns:r="http://schemas.openxmlformats.org/officeDocument/2006/relationships" id="2147483652" r:id="Red603c8d16ef41f9"/>
+    <p:sldLayoutId xmlns:r="http://schemas.openxmlformats.org/officeDocument/2006/relationships" id="2147483653" r:id="Rb6631a7d75394b93"/>
+    <p:sldLayoutId xmlns:r="http://schemas.openxmlformats.org/officeDocument/2006/relationships" id="2147483654" r:id="R22bdb61e3a364669"/>
   </p:sldLayoutIdLst>
   <p:txStyles>
     <p:titleStyle>
@@ -3938,7 +3938,7 @@
           <p:cNvPr id="7" name="">
             <a:extLst xmlns:a="http://schemas.openxmlformats.org/drawingml/2006/main">
               <a:ext uri="{FF2B5EF4-FFF2-40B4-BE49-F238E27FC236}">
-                <a16:creationId xmlns:a16="http://schemas.microsoft.com/office/drawing/2014/main" id="{AEFE12FB-A6CD-4261-B4BD-C4C54FE5AD08}"/>
+                <a16:creationId xmlns:a16="http://schemas.microsoft.com/office/drawing/2014/main" id="{149B9D4B-2E9F-42D2-97F8-0055833546F2}"/>
               </a:ext>
             </a:extLst>
           </p:cNvPr>
@@ -4059,7 +4059,7 @@
           <p:cNvPr id="2" name="">
             <a:extLst xmlns:a="http://schemas.openxmlformats.org/drawingml/2006/main">
               <a:ext uri="{FF2B5EF4-FFF2-40B4-BE49-F238E27FC236}">
-                <a16:creationId xmlns:a16="http://schemas.microsoft.com/office/drawing/2014/main" id="{9DAD33F5-67AE-4764-B7EC-AB673ACCDD80}"/>
+                <a16:creationId xmlns:a16="http://schemas.microsoft.com/office/drawing/2014/main" id="{1729F5CB-31DC-4805-80B4-F4BEBEE13824}"/>
               </a:ext>
             </a:extLst>
           </p:cNvPr>
@@ -4180,7 +4180,7 @@
           <p:cNvPr id="3" name="">
             <a:extLst xmlns:a="http://schemas.openxmlformats.org/drawingml/2006/main">
               <a:ext uri="{FF2B5EF4-FFF2-40B4-BE49-F238E27FC236}">
-                <a16:creationId xmlns:a16="http://schemas.microsoft.com/office/drawing/2014/main" id="{723A9068-AF75-40E6-9BC0-445E1A5EE3DA}"/>
+                <a16:creationId xmlns:a16="http://schemas.microsoft.com/office/drawing/2014/main" id="{A8BDF708-A0C2-47B7-8ED3-BC4345EC8D2E}"/>
               </a:ext>
             </a:extLst>
           </p:cNvPr>
@@ -4291,7 +4291,7 @@
                   <a:srgbClr val="18243C"/>
                 </a:solidFill>
               </a:rPr>
-              <a:t>От требований к</a:t>
+              <a:t>Как мы создали</a:t>
             </a:r>
           </a:p>
           <a:p xmlns:a="http://schemas.openxmlformats.org/drawingml/2006/main">
@@ -4308,7 +4308,7 @@
                   <a:srgbClr val="18243C"/>
                 </a:solidFill>
               </a:rPr>
-              <a:t>интерактивному прототипу</a:t>
+              <a:t>прототип DropCRM</a:t>
             </a:r>
           </a:p>
         </p:txBody>
@@ -4318,7 +4318,7 @@
           <p:cNvPr id="4" name="">
             <a:extLst xmlns:a="http://schemas.openxmlformats.org/drawingml/2006/main">
               <a:ext uri="{FF2B5EF4-FFF2-40B4-BE49-F238E27FC236}">
-                <a16:creationId xmlns:a16="http://schemas.microsoft.com/office/drawing/2014/main" id="{4F3FB7C1-8939-402A-B793-FEBEC1A35D50}"/>
+                <a16:creationId xmlns:a16="http://schemas.microsoft.com/office/drawing/2014/main" id="{5B8F62DF-5BF5-45FC-85DC-3271690B3DA5}"/>
               </a:ext>
             </a:extLst>
           </p:cNvPr>
@@ -4429,7 +4429,7 @@
                   <a:srgbClr val="738096"/>
                 </a:solidFill>
               </a:rPr>
-              <a:t>DropCRM · итог проекта</a:t>
+              <a:t>Наш итоговый проект</a:t>
             </a:r>
           </a:p>
         </p:txBody>
@@ -4439,7 +4439,7 @@
           <p:cNvPr id="5" name="">
             <a:extLst xmlns:a="http://schemas.openxmlformats.org/drawingml/2006/main">
               <a:ext uri="{FF2B5EF4-FFF2-40B4-BE49-F238E27FC236}">
-                <a16:creationId xmlns:a16="http://schemas.microsoft.com/office/drawing/2014/main" id="{2E3460AC-A346-4273-B583-38E33D939F25}"/>
+                <a16:creationId xmlns:a16="http://schemas.microsoft.com/office/drawing/2014/main" id="{5DFFC41C-69A5-4F9B-98BA-60870DC610F0}"/>
               </a:ext>
             </a:extLst>
           </p:cNvPr>
@@ -4560,7 +4560,7 @@
           <p:cNvPr id="6" name="">
             <a:extLst xmlns:a="http://schemas.openxmlformats.org/drawingml/2006/main">
               <a:ext uri="{FF2B5EF4-FFF2-40B4-BE49-F238E27FC236}">
-                <a16:creationId xmlns:a16="http://schemas.microsoft.com/office/drawing/2014/main" id="{7D9A48BB-5C03-4105-A52A-9CD160522763}"/>
+                <a16:creationId xmlns:a16="http://schemas.microsoft.com/office/drawing/2014/main" id="{4EE004AD-767E-4EC3-AD9C-BA1A1875A624}"/>
               </a:ext>
             </a:extLst>
           </p:cNvPr>
@@ -4570,7 +4570,7 @@
           <p:nvPr/>
         </p:nvPicPr>
         <p:blipFill>
-          <a:blip xmlns:r="http://schemas.openxmlformats.org/officeDocument/2006/relationships" xmlns:a="http://schemas.openxmlformats.org/drawingml/2006/main" r:embed="R7eaa1ad4033c42f0"/>
+          <a:blip xmlns:r="http://schemas.openxmlformats.org/officeDocument/2006/relationships" xmlns:a="http://schemas.openxmlformats.org/drawingml/2006/main" r:embed="R261e6c6bf4274856"/>
           <a:stretch xmlns:a="http://schemas.openxmlformats.org/drawingml/2006/main"/>
         </p:blipFill>
         <p:spPr>
@@ -4586,7 +4586,7 @@
     </p:spTree>
     <p:extLst>
       <p:ext uri="{BB962C8B-B14F-4D97-AF65-F5344CB8AC3E}">
-        <p14:creationId xmlns:p14="http://schemas.microsoft.com/office/powerpoint/2010/main" val="493729036"/>
+        <p14:creationId xmlns:p14="http://schemas.microsoft.com/office/powerpoint/2010/main" val="534010569"/>
       </p:ext>
     </p:extLst>
   </p:cSld>
@@ -4617,7 +4617,7 @@
           <p:cNvPr id="13" name="">
             <a:extLst xmlns:a="http://schemas.openxmlformats.org/drawingml/2006/main">
               <a:ext uri="{FF2B5EF4-FFF2-40B4-BE49-F238E27FC236}">
-                <a16:creationId xmlns:a16="http://schemas.microsoft.com/office/drawing/2014/main" id="{6576B80E-EE8C-481D-9869-6A45A27CB5E1}"/>
+                <a16:creationId xmlns:a16="http://schemas.microsoft.com/office/drawing/2014/main" id="{E35817DD-576E-4A48-A112-E7DE57A65CA2}"/>
               </a:ext>
             </a:extLst>
           </p:cNvPr>
@@ -4738,7 +4738,7 @@
           <p:cNvPr id="2" name="">
             <a:extLst xmlns:a="http://schemas.openxmlformats.org/drawingml/2006/main">
               <a:ext uri="{FF2B5EF4-FFF2-40B4-BE49-F238E27FC236}">
-                <a16:creationId xmlns:a16="http://schemas.microsoft.com/office/drawing/2014/main" id="{41D79CB0-0F19-4B9E-96DF-2A57C09CD363}"/>
+                <a16:creationId xmlns:a16="http://schemas.microsoft.com/office/drawing/2014/main" id="{D32D5EE3-AB56-49D9-8573-86176FB736A6}"/>
               </a:ext>
             </a:extLst>
           </p:cNvPr>
@@ -4859,7 +4859,7 @@
           <p:cNvPr id="3" name="">
             <a:extLst xmlns:a="http://schemas.openxmlformats.org/drawingml/2006/main">
               <a:ext uri="{FF2B5EF4-FFF2-40B4-BE49-F238E27FC236}">
-                <a16:creationId xmlns:a16="http://schemas.microsoft.com/office/drawing/2014/main" id="{3BAC070B-E0D5-4E2C-90FF-F48798ED71ED}"/>
+                <a16:creationId xmlns:a16="http://schemas.microsoft.com/office/drawing/2014/main" id="{CF532D64-8FF6-40D5-9C3A-1C44B2813676}"/>
               </a:ext>
             </a:extLst>
           </p:cNvPr>
@@ -4890,7 +4890,7 @@
           <p:cNvPr id="4" name="">
             <a:extLst xmlns:a="http://schemas.openxmlformats.org/drawingml/2006/main">
               <a:ext uri="{FF2B5EF4-FFF2-40B4-BE49-F238E27FC236}">
-                <a16:creationId xmlns:a16="http://schemas.microsoft.com/office/drawing/2014/main" id="{25C7D384-B87A-4AB1-B8F6-5E6E329B1492}"/>
+                <a16:creationId xmlns:a16="http://schemas.microsoft.com/office/drawing/2014/main" id="{DBD71925-5368-49F3-8194-228A02D09062}"/>
               </a:ext>
             </a:extLst>
           </p:cNvPr>
@@ -5001,7 +5001,7 @@
                   <a:srgbClr val="18243C"/>
                 </a:solidFill>
               </a:rPr>
-              <a:t>Для чего нужен DropCRM</a:t>
+              <a:t>Как мы связали три роли</a:t>
             </a:r>
           </a:p>
         </p:txBody>
@@ -5011,7 +5011,7 @@
           <p:cNvPr id="5" name="">
             <a:extLst xmlns:a="http://schemas.openxmlformats.org/drawingml/2006/main">
               <a:ext uri="{FF2B5EF4-FFF2-40B4-BE49-F238E27FC236}">
-                <a16:creationId xmlns:a16="http://schemas.microsoft.com/office/drawing/2014/main" id="{69030E4B-CD25-4124-9B19-6148DF57B1EC}"/>
+                <a16:creationId xmlns:a16="http://schemas.microsoft.com/office/drawing/2014/main" id="{4A5AA0D9-81C3-42D2-B1F3-0B9532A0E310}"/>
               </a:ext>
             </a:extLst>
           </p:cNvPr>
@@ -5132,7 +5132,7 @@
           <p:cNvPr id="6" name="">
             <a:extLst xmlns:a="http://schemas.openxmlformats.org/drawingml/2006/main">
               <a:ext uri="{FF2B5EF4-FFF2-40B4-BE49-F238E27FC236}">
-                <a16:creationId xmlns:a16="http://schemas.microsoft.com/office/drawing/2014/main" id="{6BEA2752-9846-41D5-B651-192ED3B93E84}"/>
+                <a16:creationId xmlns:a16="http://schemas.microsoft.com/office/drawing/2014/main" id="{5E2CCE8A-9731-4D1B-AB39-0D3196A4A01D}"/>
               </a:ext>
             </a:extLst>
           </p:cNvPr>
@@ -5253,7 +5253,7 @@
           <p:cNvPr id="7" name="">
             <a:extLst xmlns:a="http://schemas.openxmlformats.org/drawingml/2006/main">
               <a:ext uri="{FF2B5EF4-FFF2-40B4-BE49-F238E27FC236}">
-                <a16:creationId xmlns:a16="http://schemas.microsoft.com/office/drawing/2014/main" id="{618F34FC-93A0-455C-8FAA-101B2B67D91F}"/>
+                <a16:creationId xmlns:a16="http://schemas.microsoft.com/office/drawing/2014/main" id="{B0F82663-6DB1-4554-9D79-7E7471BE698A}"/>
               </a:ext>
             </a:extLst>
           </p:cNvPr>
@@ -5374,7 +5374,7 @@
           <p:cNvPr id="8" name="">
             <a:extLst xmlns:a="http://schemas.openxmlformats.org/drawingml/2006/main">
               <a:ext uri="{FF2B5EF4-FFF2-40B4-BE49-F238E27FC236}">
-                <a16:creationId xmlns:a16="http://schemas.microsoft.com/office/drawing/2014/main" id="{A339CB7F-BED9-4F58-912F-C74DA59F2556}"/>
+                <a16:creationId xmlns:a16="http://schemas.microsoft.com/office/drawing/2014/main" id="{E06163F4-BD82-47FE-AF63-534801634F15}"/>
               </a:ext>
             </a:extLst>
           </p:cNvPr>
@@ -5495,7 +5495,7 @@
           <p:cNvPr id="9" name="">
             <a:extLst xmlns:a="http://schemas.openxmlformats.org/drawingml/2006/main">
               <a:ext uri="{FF2B5EF4-FFF2-40B4-BE49-F238E27FC236}">
-                <a16:creationId xmlns:a16="http://schemas.microsoft.com/office/drawing/2014/main" id="{70203565-E055-4868-90A8-9FE62A343BB6}"/>
+                <a16:creationId xmlns:a16="http://schemas.microsoft.com/office/drawing/2014/main" id="{D294E188-F1D5-47EF-AA64-543FCFB706C1}"/>
               </a:ext>
             </a:extLst>
           </p:cNvPr>
@@ -5616,7 +5616,7 @@
           <p:cNvPr id="10" name="">
             <a:extLst xmlns:a="http://schemas.openxmlformats.org/drawingml/2006/main">
               <a:ext uri="{FF2B5EF4-FFF2-40B4-BE49-F238E27FC236}">
-                <a16:creationId xmlns:a16="http://schemas.microsoft.com/office/drawing/2014/main" id="{55F3657F-784B-422B-B2E9-AA19550154F7}"/>
+                <a16:creationId xmlns:a16="http://schemas.microsoft.com/office/drawing/2014/main" id="{EE25F2FA-99C5-4F8D-955C-C82420A42A2C}"/>
               </a:ext>
             </a:extLst>
           </p:cNvPr>
@@ -5737,7 +5737,7 @@
           <p:cNvPr id="11" name="">
             <a:extLst xmlns:a="http://schemas.openxmlformats.org/drawingml/2006/main">
               <a:ext uri="{FF2B5EF4-FFF2-40B4-BE49-F238E27FC236}">
-                <a16:creationId xmlns:a16="http://schemas.microsoft.com/office/drawing/2014/main" id="{8C3A7AF5-FEBD-4FC1-90E4-D3CCFEA6179A}"/>
+                <a16:creationId xmlns:a16="http://schemas.microsoft.com/office/drawing/2014/main" id="{C2BFC4ED-8099-417C-AF8E-6392F5529381}"/>
               </a:ext>
             </a:extLst>
           </p:cNvPr>
@@ -5858,7 +5858,7 @@
           <p:cNvPr id="12" name="">
             <a:extLst xmlns:a="http://schemas.openxmlformats.org/drawingml/2006/main">
               <a:ext uri="{FF2B5EF4-FFF2-40B4-BE49-F238E27FC236}">
-                <a16:creationId xmlns:a16="http://schemas.microsoft.com/office/drawing/2014/main" id="{2355FA99-09A6-45ED-9648-FCFDBEFF685B}"/>
+                <a16:creationId xmlns:a16="http://schemas.microsoft.com/office/drawing/2014/main" id="{1E07D1FA-ED6B-421C-B062-C199BBDDCFEF}"/>
               </a:ext>
             </a:extLst>
           </p:cNvPr>
@@ -5969,7 +5969,7 @@
                   <a:srgbClr val="18243C"/>
                 </a:solidFill>
               </a:rPr>
-              <a:t>Общий заказ связывает действия всех трёх ролей.</a:t>
+              <a:t>Мы связали действия трёх ролей через общий заказ.</a:t>
             </a:r>
           </a:p>
         </p:txBody>
@@ -5977,7 +5977,7 @@
     </p:spTree>
     <p:extLst>
       <p:ext uri="{BB962C8B-B14F-4D97-AF65-F5344CB8AC3E}">
-        <p14:creationId xmlns:p14="http://schemas.microsoft.com/office/powerpoint/2010/main" val="1570039088"/>
+        <p14:creationId xmlns:p14="http://schemas.microsoft.com/office/powerpoint/2010/main" val="130994732"/>
       </p:ext>
     </p:extLst>
   </p:cSld>
@@ -6008,7 +6008,7 @@
           <p:cNvPr id="12" name="">
             <a:extLst xmlns:a="http://schemas.openxmlformats.org/drawingml/2006/main">
               <a:ext uri="{FF2B5EF4-FFF2-40B4-BE49-F238E27FC236}">
-                <a16:creationId xmlns:a16="http://schemas.microsoft.com/office/drawing/2014/main" id="{E1E7EE0A-4737-4FB2-A223-70AAE1564FF4}"/>
+                <a16:creationId xmlns:a16="http://schemas.microsoft.com/office/drawing/2014/main" id="{F232F228-F5C9-4FC3-98B3-0B6D980E2B79}"/>
               </a:ext>
             </a:extLst>
           </p:cNvPr>
@@ -6129,7 +6129,7 @@
           <p:cNvPr id="2" name="">
             <a:extLst xmlns:a="http://schemas.openxmlformats.org/drawingml/2006/main">
               <a:ext uri="{FF2B5EF4-FFF2-40B4-BE49-F238E27FC236}">
-                <a16:creationId xmlns:a16="http://schemas.microsoft.com/office/drawing/2014/main" id="{951BABC6-532F-4D27-87EB-2F7474332697}"/>
+                <a16:creationId xmlns:a16="http://schemas.microsoft.com/office/drawing/2014/main" id="{066C4EB5-0220-4BF2-869E-7C0590960199}"/>
               </a:ext>
             </a:extLst>
           </p:cNvPr>
@@ -6250,7 +6250,7 @@
           <p:cNvPr id="3" name="">
             <a:extLst xmlns:a="http://schemas.openxmlformats.org/drawingml/2006/main">
               <a:ext uri="{FF2B5EF4-FFF2-40B4-BE49-F238E27FC236}">
-                <a16:creationId xmlns:a16="http://schemas.microsoft.com/office/drawing/2014/main" id="{13B40780-E3B1-43BC-BB0C-268AD658C677}"/>
+                <a16:creationId xmlns:a16="http://schemas.microsoft.com/office/drawing/2014/main" id="{2F22ECC8-7582-422C-9D8D-FDB394C5620F}"/>
               </a:ext>
             </a:extLst>
           </p:cNvPr>
@@ -6281,7 +6281,7 @@
           <p:cNvPr id="4" name="">
             <a:extLst xmlns:a="http://schemas.openxmlformats.org/drawingml/2006/main">
               <a:ext uri="{FF2B5EF4-FFF2-40B4-BE49-F238E27FC236}">
-                <a16:creationId xmlns:a16="http://schemas.microsoft.com/office/drawing/2014/main" id="{C07E6C24-A752-494A-8866-D18B28449309}"/>
+                <a16:creationId xmlns:a16="http://schemas.microsoft.com/office/drawing/2014/main" id="{7D6DE352-2E7C-4D83-94CC-BEA0A48D0258}"/>
               </a:ext>
             </a:extLst>
           </p:cNvPr>
@@ -6392,7 +6392,7 @@
                   <a:srgbClr val="18243C"/>
                 </a:solidFill>
               </a:rPr>
-              <a:t>Как менялся проект</a:t>
+              <a:t>Как мы меняли проект</a:t>
             </a:r>
           </a:p>
         </p:txBody>
@@ -6402,7 +6402,7 @@
           <p:cNvPr id="5" name="">
             <a:extLst xmlns:a="http://schemas.openxmlformats.org/drawingml/2006/main">
               <a:ext uri="{FF2B5EF4-FFF2-40B4-BE49-F238E27FC236}">
-                <a16:creationId xmlns:a16="http://schemas.microsoft.com/office/drawing/2014/main" id="{D54DAB36-EE13-4D70-B0E9-968D8F6F6E86}"/>
+                <a16:creationId xmlns:a16="http://schemas.microsoft.com/office/drawing/2014/main" id="{60EE4D8C-5B97-43D3-8636-95583AA207E7}"/>
               </a:ext>
             </a:extLst>
           </p:cNvPr>
@@ -6523,7 +6523,7 @@
           <p:cNvPr id="6" name="">
             <a:extLst xmlns:a="http://schemas.openxmlformats.org/drawingml/2006/main">
               <a:ext uri="{FF2B5EF4-FFF2-40B4-BE49-F238E27FC236}">
-                <a16:creationId xmlns:a16="http://schemas.microsoft.com/office/drawing/2014/main" id="{8E3F3AE2-F1BA-40D3-B447-C8848A4A0EBB}"/>
+                <a16:creationId xmlns:a16="http://schemas.microsoft.com/office/drawing/2014/main" id="{30EA296C-CA05-4670-89B3-F5EB6B876AA4}"/>
               </a:ext>
             </a:extLst>
           </p:cNvPr>
@@ -6634,7 +6634,7 @@
                   <a:srgbClr val="18243C"/>
                 </a:solidFill>
               </a:rPr>
-              <a:t>Исходное ТЗ</a:t>
+              <a:t>Наше ТЗ</a:t>
             </a:r>
           </a:p>
         </p:txBody>
@@ -6644,7 +6644,7 @@
           <p:cNvPr id="7" name="">
             <a:extLst xmlns:a="http://schemas.openxmlformats.org/drawingml/2006/main">
               <a:ext uri="{FF2B5EF4-FFF2-40B4-BE49-F238E27FC236}">
-                <a16:creationId xmlns:a16="http://schemas.microsoft.com/office/drawing/2014/main" id="{3AB2430A-2850-4031-9A72-098C9249BDDB}"/>
+                <a16:creationId xmlns:a16="http://schemas.microsoft.com/office/drawing/2014/main" id="{12E9C59D-ABD5-4271-8ACA-1A181674915B}"/>
               </a:ext>
             </a:extLst>
           </p:cNvPr>
@@ -6755,7 +6755,7 @@
                   <a:srgbClr val="18243C"/>
                 </a:solidFill>
               </a:rPr>
-              <a:t>Широкая система: каталог, много позиций в заказе, управление остатками, аналитика, мобильная версия и серверные требования.</a:t>
+              <a:t>Сначала мы описали широкую систему: каталог, несколько позиций в заказе, аналитику, мобильную версию и серверные требования.</a:t>
             </a:r>
           </a:p>
         </p:txBody>
@@ -6765,7 +6765,7 @@
           <p:cNvPr id="8" name="">
             <a:extLst xmlns:a="http://schemas.openxmlformats.org/drawingml/2006/main">
               <a:ext uri="{FF2B5EF4-FFF2-40B4-BE49-F238E27FC236}">
-                <a16:creationId xmlns:a16="http://schemas.microsoft.com/office/drawing/2014/main" id="{17A75E9F-EADD-4387-8C92-EA3468E6BC9B}"/>
+                <a16:creationId xmlns:a16="http://schemas.microsoft.com/office/drawing/2014/main" id="{EDA6B0FE-6C54-4385-972D-101B39428D96}"/>
               </a:ext>
             </a:extLst>
           </p:cNvPr>
@@ -6876,7 +6876,7 @@
                   <a:srgbClr val="285BEB"/>
                 </a:solidFill>
               </a:rPr>
-              <a:t>Итоговый прототип</a:t>
+              <a:t>Наш прототип</a:t>
             </a:r>
           </a:p>
         </p:txBody>
@@ -6886,7 +6886,7 @@
           <p:cNvPr id="9" name="">
             <a:extLst xmlns:a="http://schemas.openxmlformats.org/drawingml/2006/main">
               <a:ext uri="{FF2B5EF4-FFF2-40B4-BE49-F238E27FC236}">
-                <a16:creationId xmlns:a16="http://schemas.microsoft.com/office/drawing/2014/main" id="{1F9387A1-2D0C-48E3-82FE-B286582DB11B}"/>
+                <a16:creationId xmlns:a16="http://schemas.microsoft.com/office/drawing/2014/main" id="{29E8FB6D-0517-42CD-A37B-1D725469BE29}"/>
               </a:ext>
             </a:extLst>
           </p:cNvPr>
@@ -6997,7 +6997,7 @@
                   <a:srgbClr val="18243C"/>
                 </a:solidFill>
               </a:rPr>
-              <a:t>Сквозной путь одного заказа одному поставщику. Подтверждение условий, оплата, отправление и отдельные рабочие пространства трёх ролей.</a:t>
+              <a:t>Затем мы сосредоточились на одном заказе одному поставщику и показали его путь до отправления в рабочих пространствах трёх ролей.</a:t>
             </a:r>
           </a:p>
         </p:txBody>
@@ -7007,7 +7007,7 @@
           <p:cNvPr id="10" name="">
             <a:extLst xmlns:a="http://schemas.openxmlformats.org/drawingml/2006/main">
               <a:ext uri="{FF2B5EF4-FFF2-40B4-BE49-F238E27FC236}">
-                <a16:creationId xmlns:a16="http://schemas.microsoft.com/office/drawing/2014/main" id="{DE8B8BFC-ABC9-4A43-A213-2D5C217DE5B6}"/>
+                <a16:creationId xmlns:a16="http://schemas.microsoft.com/office/drawing/2014/main" id="{98F66D9D-404E-4658-979B-1E66DED85C54}"/>
               </a:ext>
             </a:extLst>
           </p:cNvPr>
@@ -7038,7 +7038,7 @@
           <p:cNvPr id="11" name="">
             <a:extLst xmlns:a="http://schemas.openxmlformats.org/drawingml/2006/main">
               <a:ext uri="{FF2B5EF4-FFF2-40B4-BE49-F238E27FC236}">
-                <a16:creationId xmlns:a16="http://schemas.microsoft.com/office/drawing/2014/main" id="{0EFA82D9-D034-49A1-814A-4E8FCFBC1B20}"/>
+                <a16:creationId xmlns:a16="http://schemas.microsoft.com/office/drawing/2014/main" id="{21BA8A85-402F-4C02-9C3C-A181F31CFE92}"/>
               </a:ext>
             </a:extLst>
           </p:cNvPr>
@@ -7149,7 +7149,7 @@
                   <a:srgbClr val="738096"/>
                 </a:solidFill>
               </a:rPr>
-              <a:t>ТЗ сохранено как исторический документ. Изменения объяснены в итоговом отчёте.</a:t>
+              <a:t>Как изменился объём проекта, мы объяснили в итоговом отчёте.</a:t>
             </a:r>
           </a:p>
         </p:txBody>
@@ -7157,7 +7157,7 @@
     </p:spTree>
     <p:extLst>
       <p:ext uri="{BB962C8B-B14F-4D97-AF65-F5344CB8AC3E}">
-        <p14:creationId xmlns:p14="http://schemas.microsoft.com/office/powerpoint/2010/main" val="1621217087"/>
+        <p14:creationId xmlns:p14="http://schemas.microsoft.com/office/powerpoint/2010/main" val="82656569"/>
       </p:ext>
     </p:extLst>
   </p:cSld>
@@ -7188,7 +7188,7 @@
           <p:cNvPr id="8" name="">
             <a:extLst xmlns:a="http://schemas.openxmlformats.org/drawingml/2006/main">
               <a:ext uri="{FF2B5EF4-FFF2-40B4-BE49-F238E27FC236}">
-                <a16:creationId xmlns:a16="http://schemas.microsoft.com/office/drawing/2014/main" id="{751AC5B4-F505-4943-9A1B-2D0EAF69552A}"/>
+                <a16:creationId xmlns:a16="http://schemas.microsoft.com/office/drawing/2014/main" id="{FF7DB3D9-F733-4155-B053-73D1C8CBCFB2}"/>
               </a:ext>
             </a:extLst>
           </p:cNvPr>
@@ -7309,7 +7309,7 @@
           <p:cNvPr id="2" name="">
             <a:extLst xmlns:a="http://schemas.openxmlformats.org/drawingml/2006/main">
               <a:ext uri="{FF2B5EF4-FFF2-40B4-BE49-F238E27FC236}">
-                <a16:creationId xmlns:a16="http://schemas.microsoft.com/office/drawing/2014/main" id="{AA4F2E95-FE5C-4E12-9DF9-EE5652C3E725}"/>
+                <a16:creationId xmlns:a16="http://schemas.microsoft.com/office/drawing/2014/main" id="{74A0D35C-9C45-4126-929A-EC436AD05BE8}"/>
               </a:ext>
             </a:extLst>
           </p:cNvPr>
@@ -7430,7 +7430,7 @@
           <p:cNvPr id="3" name="">
             <a:extLst xmlns:a="http://schemas.openxmlformats.org/drawingml/2006/main">
               <a:ext uri="{FF2B5EF4-FFF2-40B4-BE49-F238E27FC236}">
-                <a16:creationId xmlns:a16="http://schemas.microsoft.com/office/drawing/2014/main" id="{DE10E731-D13C-4532-ABF4-0A11C3F3215B}"/>
+                <a16:creationId xmlns:a16="http://schemas.microsoft.com/office/drawing/2014/main" id="{436DF54A-0366-4845-8B22-2F5582CDBF43}"/>
               </a:ext>
             </a:extLst>
           </p:cNvPr>
@@ -7461,7 +7461,7 @@
           <p:cNvPr id="4" name="">
             <a:extLst xmlns:a="http://schemas.openxmlformats.org/drawingml/2006/main">
               <a:ext uri="{FF2B5EF4-FFF2-40B4-BE49-F238E27FC236}">
-                <a16:creationId xmlns:a16="http://schemas.microsoft.com/office/drawing/2014/main" id="{DEEA449F-C313-4624-8A84-3D121AD5669D}"/>
+                <a16:creationId xmlns:a16="http://schemas.microsoft.com/office/drawing/2014/main" id="{A105B966-D573-43CF-B828-5D94DCA05D56}"/>
               </a:ext>
             </a:extLst>
           </p:cNvPr>
@@ -7572,7 +7572,7 @@
                   <a:srgbClr val="18243C"/>
                 </a:solidFill>
               </a:rPr>
-              <a:t>От сценария к структуре экранов</a:t>
+              <a:t>Как мы проектировали экраны</a:t>
             </a:r>
           </a:p>
         </p:txBody>
@@ -7582,7 +7582,7 @@
           <p:cNvPr id="5" name="">
             <a:extLst xmlns:a="http://schemas.openxmlformats.org/drawingml/2006/main">
               <a:ext uri="{FF2B5EF4-FFF2-40B4-BE49-F238E27FC236}">
-                <a16:creationId xmlns:a16="http://schemas.microsoft.com/office/drawing/2014/main" id="{FE51B61A-31C6-4C61-B1DF-81DA54DD3AC0}"/>
+                <a16:creationId xmlns:a16="http://schemas.microsoft.com/office/drawing/2014/main" id="{88B0DFD3-A92D-468A-B7DA-F2DBD80779D3}"/>
               </a:ext>
             </a:extLst>
           </p:cNvPr>
@@ -7703,7 +7703,7 @@
           <p:cNvPr id="6" name="">
             <a:extLst xmlns:a="http://schemas.openxmlformats.org/drawingml/2006/main">
               <a:ext uri="{FF2B5EF4-FFF2-40B4-BE49-F238E27FC236}">
-                <a16:creationId xmlns:a16="http://schemas.microsoft.com/office/drawing/2014/main" id="{6B16A2E6-8443-462B-B832-ECBACA6547AE}"/>
+                <a16:creationId xmlns:a16="http://schemas.microsoft.com/office/drawing/2014/main" id="{1D494BBE-186F-403F-86B4-83647BE32653}"/>
               </a:ext>
             </a:extLst>
           </p:cNvPr>
@@ -7814,7 +7814,7 @@
                   <a:srgbClr val="18243C"/>
                 </a:solidFill>
               </a:rPr>
-              <a:t>Ранний пользовательский поток показывал поиск предложения, карточку товара, наценку и добавление в личный каталог.</a:t>
+              <a:t>Сначала мы показали в вайрфреймах поиск предложения, карточку товара, наценку и добавление в личный каталог.</a:t>
             </a:r>
           </a:p>
         </p:txBody>
@@ -7824,7 +7824,7 @@
           <p:cNvPr id="7" name="">
             <a:extLst xmlns:a="http://schemas.openxmlformats.org/drawingml/2006/main">
               <a:ext uri="{FF2B5EF4-FFF2-40B4-BE49-F238E27FC236}">
-                <a16:creationId xmlns:a16="http://schemas.microsoft.com/office/drawing/2014/main" id="{FD7AC882-71EB-4BAE-BC50-75F6E93704E8}"/>
+                <a16:creationId xmlns:a16="http://schemas.microsoft.com/office/drawing/2014/main" id="{5C702519-D9EF-4254-AEFE-24216781737A}"/>
               </a:ext>
             </a:extLst>
           </p:cNvPr>
@@ -7834,7 +7834,7 @@
           <p:nvPr/>
         </p:nvPicPr>
         <p:blipFill>
-          <a:blip xmlns:r="http://schemas.openxmlformats.org/officeDocument/2006/relationships" xmlns:a="http://schemas.openxmlformats.org/drawingml/2006/main" r:embed="R949c7049e03a4754"/>
+          <a:blip xmlns:r="http://schemas.openxmlformats.org/officeDocument/2006/relationships" xmlns:a="http://schemas.openxmlformats.org/drawingml/2006/main" r:embed="R5d623046bd9f4f25"/>
           <a:stretch xmlns:a="http://schemas.openxmlformats.org/drawingml/2006/main"/>
         </p:blipFill>
         <p:spPr>
@@ -7850,7 +7850,7 @@
     </p:spTree>
     <p:extLst>
       <p:ext uri="{BB962C8B-B14F-4D97-AF65-F5344CB8AC3E}">
-        <p14:creationId xmlns:p14="http://schemas.microsoft.com/office/powerpoint/2010/main" val="1091943927"/>
+        <p14:creationId xmlns:p14="http://schemas.microsoft.com/office/powerpoint/2010/main" val="1956726254"/>
       </p:ext>
     </p:extLst>
   </p:cSld>
@@ -7881,7 +7881,7 @@
           <p:cNvPr id="27" name="">
             <a:extLst xmlns:a="http://schemas.openxmlformats.org/drawingml/2006/main">
               <a:ext uri="{FF2B5EF4-FFF2-40B4-BE49-F238E27FC236}">
-                <a16:creationId xmlns:a16="http://schemas.microsoft.com/office/drawing/2014/main" id="{A7F15B46-9F44-4E5A-B301-DF658DDD93E4}"/>
+                <a16:creationId xmlns:a16="http://schemas.microsoft.com/office/drawing/2014/main" id="{7D037B5E-45C8-4894-A89A-D102735F79D5}"/>
               </a:ext>
             </a:extLst>
           </p:cNvPr>
@@ -8002,7 +8002,7 @@
           <p:cNvPr id="2" name="">
             <a:extLst xmlns:a="http://schemas.openxmlformats.org/drawingml/2006/main">
               <a:ext uri="{FF2B5EF4-FFF2-40B4-BE49-F238E27FC236}">
-                <a16:creationId xmlns:a16="http://schemas.microsoft.com/office/drawing/2014/main" id="{B56508B1-7505-4687-B56C-7D043CE166F7}"/>
+                <a16:creationId xmlns:a16="http://schemas.microsoft.com/office/drawing/2014/main" id="{7202F61D-1805-42C9-AB02-941CFF52DA0E}"/>
               </a:ext>
             </a:extLst>
           </p:cNvPr>
@@ -8123,7 +8123,7 @@
           <p:cNvPr id="3" name="">
             <a:extLst xmlns:a="http://schemas.openxmlformats.org/drawingml/2006/main">
               <a:ext uri="{FF2B5EF4-FFF2-40B4-BE49-F238E27FC236}">
-                <a16:creationId xmlns:a16="http://schemas.microsoft.com/office/drawing/2014/main" id="{F21774ED-8856-4107-BEC2-0946B9616992}"/>
+                <a16:creationId xmlns:a16="http://schemas.microsoft.com/office/drawing/2014/main" id="{77373B3B-2397-4FEF-BB34-066A529E641A}"/>
               </a:ext>
             </a:extLst>
           </p:cNvPr>
@@ -8154,7 +8154,7 @@
           <p:cNvPr id="4" name="">
             <a:extLst xmlns:a="http://schemas.openxmlformats.org/drawingml/2006/main">
               <a:ext uri="{FF2B5EF4-FFF2-40B4-BE49-F238E27FC236}">
-                <a16:creationId xmlns:a16="http://schemas.microsoft.com/office/drawing/2014/main" id="{73763187-999D-4F09-9C91-7A157CE8413E}"/>
+                <a16:creationId xmlns:a16="http://schemas.microsoft.com/office/drawing/2014/main" id="{22360943-B3F8-468A-B780-70285B57537E}"/>
               </a:ext>
             </a:extLst>
           </p:cNvPr>
@@ -8265,7 +8265,7 @@
                   <a:srgbClr val="18243C"/>
                 </a:solidFill>
               </a:rPr>
-              <a:t>Заказ DC-0101 проверяет логику</a:t>
+              <a:t>На DC-0101 мы проверили расчёты</a:t>
             </a:r>
           </a:p>
         </p:txBody>
@@ -8275,7 +8275,7 @@
           <p:cNvPr id="5" name="">
             <a:extLst xmlns:a="http://schemas.openxmlformats.org/drawingml/2006/main">
               <a:ext uri="{FF2B5EF4-FFF2-40B4-BE49-F238E27FC236}">
-                <a16:creationId xmlns:a16="http://schemas.microsoft.com/office/drawing/2014/main" id="{77223365-0A9E-4EA7-A4E0-E733C7113310}"/>
+                <a16:creationId xmlns:a16="http://schemas.microsoft.com/office/drawing/2014/main" id="{4ABA70A0-817B-4018-AF36-583AB63FF21F}"/>
               </a:ext>
             </a:extLst>
           </p:cNvPr>
@@ -8396,7 +8396,7 @@
           <p:cNvPr id="6" name="">
             <a:extLst xmlns:a="http://schemas.openxmlformats.org/drawingml/2006/main">
               <a:ext uri="{FF2B5EF4-FFF2-40B4-BE49-F238E27FC236}">
-                <a16:creationId xmlns:a16="http://schemas.microsoft.com/office/drawing/2014/main" id="{3FE51005-1367-4E9B-B154-11E9F01E30BE}"/>
+                <a16:creationId xmlns:a16="http://schemas.microsoft.com/office/drawing/2014/main" id="{AC279D3B-C316-40A5-9BC9-34A3B80E10C8}"/>
               </a:ext>
             </a:extLst>
           </p:cNvPr>
@@ -8517,7 +8517,7 @@
           <p:cNvPr id="7" name="">
             <a:extLst xmlns:a="http://schemas.openxmlformats.org/drawingml/2006/main">
               <a:ext uri="{FF2B5EF4-FFF2-40B4-BE49-F238E27FC236}">
-                <a16:creationId xmlns:a16="http://schemas.microsoft.com/office/drawing/2014/main" id="{F5ECAE49-1C23-4CB1-84F7-833275A96281}"/>
+                <a16:creationId xmlns:a16="http://schemas.microsoft.com/office/drawing/2014/main" id="{85B3225C-49C5-4E30-9720-3F2AD47A10E0}"/>
               </a:ext>
             </a:extLst>
           </p:cNvPr>
@@ -8638,7 +8638,7 @@
           <p:cNvPr id="8" name="">
             <a:extLst xmlns:a="http://schemas.openxmlformats.org/drawingml/2006/main">
               <a:ext uri="{FF2B5EF4-FFF2-40B4-BE49-F238E27FC236}">
-                <a16:creationId xmlns:a16="http://schemas.microsoft.com/office/drawing/2014/main" id="{2A5AF8F0-EAED-49D3-9FC4-09C260D8237E}"/>
+                <a16:creationId xmlns:a16="http://schemas.microsoft.com/office/drawing/2014/main" id="{178895D1-C61D-4544-8F87-B6DCBE4C5B23}"/>
               </a:ext>
             </a:extLst>
           </p:cNvPr>
@@ -8759,7 +8759,7 @@
           <p:cNvPr id="9" name="">
             <a:extLst xmlns:a="http://schemas.openxmlformats.org/drawingml/2006/main">
               <a:ext uri="{FF2B5EF4-FFF2-40B4-BE49-F238E27FC236}">
-                <a16:creationId xmlns:a16="http://schemas.microsoft.com/office/drawing/2014/main" id="{1ED7E3AF-29CB-46F5-8460-0A8E334AC28C}"/>
+                <a16:creationId xmlns:a16="http://schemas.microsoft.com/office/drawing/2014/main" id="{706B4A9B-239E-43E7-AC00-8EDCD084C9C6}"/>
               </a:ext>
             </a:extLst>
           </p:cNvPr>
@@ -8790,7 +8790,7 @@
           <p:cNvPr id="10" name="">
             <a:extLst xmlns:a="http://schemas.openxmlformats.org/drawingml/2006/main">
               <a:ext uri="{FF2B5EF4-FFF2-40B4-BE49-F238E27FC236}">
-                <a16:creationId xmlns:a16="http://schemas.microsoft.com/office/drawing/2014/main" id="{89DB7FBA-7A12-4935-9A06-B20BB504BFEC}"/>
+                <a16:creationId xmlns:a16="http://schemas.microsoft.com/office/drawing/2014/main" id="{F231278E-E2C4-462B-8126-9617A8C3B7AF}"/>
               </a:ext>
             </a:extLst>
           </p:cNvPr>
@@ -8911,7 +8911,7 @@
           <p:cNvPr id="11" name="">
             <a:extLst xmlns:a="http://schemas.openxmlformats.org/drawingml/2006/main">
               <a:ext uri="{FF2B5EF4-FFF2-40B4-BE49-F238E27FC236}">
-                <a16:creationId xmlns:a16="http://schemas.microsoft.com/office/drawing/2014/main" id="{5459DEC7-FC1F-4326-A0BC-0F11E99E04BF}"/>
+                <a16:creationId xmlns:a16="http://schemas.microsoft.com/office/drawing/2014/main" id="{3EAFB8F9-E379-44CD-B927-45402597356D}"/>
               </a:ext>
             </a:extLst>
           </p:cNvPr>
@@ -9032,7 +9032,7 @@
           <p:cNvPr id="12" name="">
             <a:extLst xmlns:a="http://schemas.openxmlformats.org/drawingml/2006/main">
               <a:ext uri="{FF2B5EF4-FFF2-40B4-BE49-F238E27FC236}">
-                <a16:creationId xmlns:a16="http://schemas.microsoft.com/office/drawing/2014/main" id="{B04A3D5C-47E2-4971-B180-B53A6D26F561}"/>
+                <a16:creationId xmlns:a16="http://schemas.microsoft.com/office/drawing/2014/main" id="{342D46C8-999C-4760-A2FB-7867174AC0F6}"/>
               </a:ext>
             </a:extLst>
           </p:cNvPr>
@@ -9153,7 +9153,7 @@
           <p:cNvPr id="13" name="">
             <a:extLst xmlns:a="http://schemas.openxmlformats.org/drawingml/2006/main">
               <a:ext uri="{FF2B5EF4-FFF2-40B4-BE49-F238E27FC236}">
-                <a16:creationId xmlns:a16="http://schemas.microsoft.com/office/drawing/2014/main" id="{2C706A48-2C8B-47A4-A676-130C2B98DBE6}"/>
+                <a16:creationId xmlns:a16="http://schemas.microsoft.com/office/drawing/2014/main" id="{51044D22-9FD2-49F2-8FF9-9CB12EA5468E}"/>
               </a:ext>
             </a:extLst>
           </p:cNvPr>
@@ -9184,7 +9184,7 @@
           <p:cNvPr id="14" name="">
             <a:extLst xmlns:a="http://schemas.openxmlformats.org/drawingml/2006/main">
               <a:ext uri="{FF2B5EF4-FFF2-40B4-BE49-F238E27FC236}">
-                <a16:creationId xmlns:a16="http://schemas.microsoft.com/office/drawing/2014/main" id="{6612FDBC-64A1-4580-836B-EAA78D1719D9}"/>
+                <a16:creationId xmlns:a16="http://schemas.microsoft.com/office/drawing/2014/main" id="{DF308FF9-3469-4801-B455-14DD636B4F90}"/>
               </a:ext>
             </a:extLst>
           </p:cNvPr>
@@ -9305,7 +9305,7 @@
           <p:cNvPr id="15" name="">
             <a:extLst xmlns:a="http://schemas.openxmlformats.org/drawingml/2006/main">
               <a:ext uri="{FF2B5EF4-FFF2-40B4-BE49-F238E27FC236}">
-                <a16:creationId xmlns:a16="http://schemas.microsoft.com/office/drawing/2014/main" id="{E5BF9369-39A8-446A-87CB-2BA6118C8123}"/>
+                <a16:creationId xmlns:a16="http://schemas.microsoft.com/office/drawing/2014/main" id="{BAA57B55-0E37-45E9-87B7-BDE3B17711AF}"/>
               </a:ext>
             </a:extLst>
           </p:cNvPr>
@@ -9426,7 +9426,7 @@
           <p:cNvPr id="16" name="">
             <a:extLst xmlns:a="http://schemas.openxmlformats.org/drawingml/2006/main">
               <a:ext uri="{FF2B5EF4-FFF2-40B4-BE49-F238E27FC236}">
-                <a16:creationId xmlns:a16="http://schemas.microsoft.com/office/drawing/2014/main" id="{6631882D-F726-40FA-A4EE-2B7F3A82C62B}"/>
+                <a16:creationId xmlns:a16="http://schemas.microsoft.com/office/drawing/2014/main" id="{9A54B89B-BE20-4104-9046-446B859C0337}"/>
               </a:ext>
             </a:extLst>
           </p:cNvPr>
@@ -9547,7 +9547,7 @@
           <p:cNvPr id="17" name="">
             <a:extLst xmlns:a="http://schemas.openxmlformats.org/drawingml/2006/main">
               <a:ext uri="{FF2B5EF4-FFF2-40B4-BE49-F238E27FC236}">
-                <a16:creationId xmlns:a16="http://schemas.microsoft.com/office/drawing/2014/main" id="{BCD54DB3-2A64-440E-BEEA-3472B2623AE3}"/>
+                <a16:creationId xmlns:a16="http://schemas.microsoft.com/office/drawing/2014/main" id="{47058512-98DA-4604-9C43-10C1338B50B4}"/>
               </a:ext>
             </a:extLst>
           </p:cNvPr>
@@ -9578,7 +9578,7 @@
           <p:cNvPr id="18" name="">
             <a:extLst xmlns:a="http://schemas.openxmlformats.org/drawingml/2006/main">
               <a:ext uri="{FF2B5EF4-FFF2-40B4-BE49-F238E27FC236}">
-                <a16:creationId xmlns:a16="http://schemas.microsoft.com/office/drawing/2014/main" id="{00F5256D-28DA-44A1-A0A5-B04C56F5BF26}"/>
+                <a16:creationId xmlns:a16="http://schemas.microsoft.com/office/drawing/2014/main" id="{2A2E75A9-D303-4F5F-9E73-75E606E374C0}"/>
               </a:ext>
             </a:extLst>
           </p:cNvPr>
@@ -9699,7 +9699,7 @@
           <p:cNvPr id="19" name="">
             <a:extLst xmlns:a="http://schemas.openxmlformats.org/drawingml/2006/main">
               <a:ext uri="{FF2B5EF4-FFF2-40B4-BE49-F238E27FC236}">
-                <a16:creationId xmlns:a16="http://schemas.microsoft.com/office/drawing/2014/main" id="{9B4BFFA0-A499-48D7-9CD5-116B31D3E41A}"/>
+                <a16:creationId xmlns:a16="http://schemas.microsoft.com/office/drawing/2014/main" id="{EBF40076-0F7F-4FFC-9585-5CC4EC13CE63}"/>
               </a:ext>
             </a:extLst>
           </p:cNvPr>
@@ -9820,7 +9820,7 @@
           <p:cNvPr id="20" name="">
             <a:extLst xmlns:a="http://schemas.openxmlformats.org/drawingml/2006/main">
               <a:ext uri="{FF2B5EF4-FFF2-40B4-BE49-F238E27FC236}">
-                <a16:creationId xmlns:a16="http://schemas.microsoft.com/office/drawing/2014/main" id="{FB25ACBE-8011-45E6-BE84-E4DCAD580F77}"/>
+                <a16:creationId xmlns:a16="http://schemas.microsoft.com/office/drawing/2014/main" id="{625F479B-D7DC-43BF-BDB5-E52DDB38C5D2}"/>
               </a:ext>
             </a:extLst>
           </p:cNvPr>
@@ -9941,7 +9941,7 @@
           <p:cNvPr id="21" name="">
             <a:extLst xmlns:a="http://schemas.openxmlformats.org/drawingml/2006/main">
               <a:ext uri="{FF2B5EF4-FFF2-40B4-BE49-F238E27FC236}">
-                <a16:creationId xmlns:a16="http://schemas.microsoft.com/office/drawing/2014/main" id="{9610BFFF-A8FC-476D-9C14-0A13D646594A}"/>
+                <a16:creationId xmlns:a16="http://schemas.microsoft.com/office/drawing/2014/main" id="{96A1550D-5A82-47E4-A6D2-9875A8C00D30}"/>
               </a:ext>
             </a:extLst>
           </p:cNvPr>
@@ -9972,7 +9972,7 @@
           <p:cNvPr id="22" name="">
             <a:extLst xmlns:a="http://schemas.openxmlformats.org/drawingml/2006/main">
               <a:ext uri="{FF2B5EF4-FFF2-40B4-BE49-F238E27FC236}">
-                <a16:creationId xmlns:a16="http://schemas.microsoft.com/office/drawing/2014/main" id="{6CD6F44C-9400-4FE0-A189-8BC644972232}"/>
+                <a16:creationId xmlns:a16="http://schemas.microsoft.com/office/drawing/2014/main" id="{B2F3D2D9-2F29-413E-B0B9-0DAE6E5BC39B}"/>
               </a:ext>
             </a:extLst>
           </p:cNvPr>
@@ -10093,7 +10093,7 @@
           <p:cNvPr id="23" name="">
             <a:extLst xmlns:a="http://schemas.openxmlformats.org/drawingml/2006/main">
               <a:ext uri="{FF2B5EF4-FFF2-40B4-BE49-F238E27FC236}">
-                <a16:creationId xmlns:a16="http://schemas.microsoft.com/office/drawing/2014/main" id="{C3C64EDF-6BBA-413D-8062-9BEEA80E2733}"/>
+                <a16:creationId xmlns:a16="http://schemas.microsoft.com/office/drawing/2014/main" id="{3637F7B1-8271-4BA7-8A04-82B85775B17F}"/>
               </a:ext>
             </a:extLst>
           </p:cNvPr>
@@ -10214,7 +10214,7 @@
           <p:cNvPr id="24" name="">
             <a:extLst xmlns:a="http://schemas.openxmlformats.org/drawingml/2006/main">
               <a:ext uri="{FF2B5EF4-FFF2-40B4-BE49-F238E27FC236}">
-                <a16:creationId xmlns:a16="http://schemas.microsoft.com/office/drawing/2014/main" id="{4AA8B693-5467-402A-8349-B3F273C7003E}"/>
+                <a16:creationId xmlns:a16="http://schemas.microsoft.com/office/drawing/2014/main" id="{9C829105-4D93-4DCC-BB97-16F2E61B1267}"/>
               </a:ext>
             </a:extLst>
           </p:cNvPr>
@@ -10335,7 +10335,7 @@
           <p:cNvPr id="25" name="">
             <a:extLst xmlns:a="http://schemas.openxmlformats.org/drawingml/2006/main">
               <a:ext uri="{FF2B5EF4-FFF2-40B4-BE49-F238E27FC236}">
-                <a16:creationId xmlns:a16="http://schemas.microsoft.com/office/drawing/2014/main" id="{2B7BBDCD-B9E1-4230-BA63-E89A51395815}"/>
+                <a16:creationId xmlns:a16="http://schemas.microsoft.com/office/drawing/2014/main" id="{8E4E4C2A-17B7-432C-86AB-FA064AF7A685}"/>
               </a:ext>
             </a:extLst>
           </p:cNvPr>
@@ -10366,7 +10366,7 @@
           <p:cNvPr id="26" name="">
             <a:extLst xmlns:a="http://schemas.openxmlformats.org/drawingml/2006/main">
               <a:ext uri="{FF2B5EF4-FFF2-40B4-BE49-F238E27FC236}">
-                <a16:creationId xmlns:a16="http://schemas.microsoft.com/office/drawing/2014/main" id="{B1476ECA-6972-4453-AF63-4F2E91F9F694}"/>
+                <a16:creationId xmlns:a16="http://schemas.microsoft.com/office/drawing/2014/main" id="{CFE5BB0E-B7C2-445C-AA31-5C3D01E41DCB}"/>
               </a:ext>
             </a:extLst>
           </p:cNvPr>
@@ -10477,7 +10477,7 @@
                   <a:srgbClr val="285BEB"/>
                 </a:solidFill>
               </a:rPr>
-              <a:t>До подтверждения поставщика оплата недоступна.</a:t>
+              <a:t>Пока поставщик не подтвердил условия, мы не открываем оплату.</a:t>
             </a:r>
           </a:p>
         </p:txBody>
@@ -10485,7 +10485,7 @@
     </p:spTree>
     <p:extLst>
       <p:ext uri="{BB962C8B-B14F-4D97-AF65-F5344CB8AC3E}">
-        <p14:creationId xmlns:p14="http://schemas.microsoft.com/office/powerpoint/2010/main" val="422592368"/>
+        <p14:creationId xmlns:p14="http://schemas.microsoft.com/office/powerpoint/2010/main" val="957383058"/>
       </p:ext>
     </p:extLst>
   </p:cSld>
@@ -10516,7 +10516,7 @@
           <p:cNvPr id="13" name="">
             <a:extLst xmlns:a="http://schemas.openxmlformats.org/drawingml/2006/main">
               <a:ext uri="{FF2B5EF4-FFF2-40B4-BE49-F238E27FC236}">
-                <a16:creationId xmlns:a16="http://schemas.microsoft.com/office/drawing/2014/main" id="{6478A53E-54F5-4E8D-8594-DB321C8332B7}"/>
+                <a16:creationId xmlns:a16="http://schemas.microsoft.com/office/drawing/2014/main" id="{048684CF-A7B2-488B-A820-F00CD43A89B4}"/>
               </a:ext>
             </a:extLst>
           </p:cNvPr>
@@ -10637,7 +10637,7 @@
           <p:cNvPr id="2" name="">
             <a:extLst xmlns:a="http://schemas.openxmlformats.org/drawingml/2006/main">
               <a:ext uri="{FF2B5EF4-FFF2-40B4-BE49-F238E27FC236}">
-                <a16:creationId xmlns:a16="http://schemas.microsoft.com/office/drawing/2014/main" id="{EF30A69C-B606-46D5-A302-45F520C6E0A0}"/>
+                <a16:creationId xmlns:a16="http://schemas.microsoft.com/office/drawing/2014/main" id="{E67AA2B7-46C6-44E4-B29E-1798DF6B6993}"/>
               </a:ext>
             </a:extLst>
           </p:cNvPr>
@@ -10758,7 +10758,7 @@
           <p:cNvPr id="3" name="">
             <a:extLst xmlns:a="http://schemas.openxmlformats.org/drawingml/2006/main">
               <a:ext uri="{FF2B5EF4-FFF2-40B4-BE49-F238E27FC236}">
-                <a16:creationId xmlns:a16="http://schemas.microsoft.com/office/drawing/2014/main" id="{DD3AAFBB-DB47-4F96-B4D1-A5212FB13369}"/>
+                <a16:creationId xmlns:a16="http://schemas.microsoft.com/office/drawing/2014/main" id="{A9CB659D-0D24-487E-809B-3BF1DC770BDD}"/>
               </a:ext>
             </a:extLst>
           </p:cNvPr>
@@ -10789,7 +10789,7 @@
           <p:cNvPr id="4" name="">
             <a:extLst xmlns:a="http://schemas.openxmlformats.org/drawingml/2006/main">
               <a:ext uri="{FF2B5EF4-FFF2-40B4-BE49-F238E27FC236}">
-                <a16:creationId xmlns:a16="http://schemas.microsoft.com/office/drawing/2014/main" id="{8F630E00-7352-40DC-9424-2FC31075657D}"/>
+                <a16:creationId xmlns:a16="http://schemas.microsoft.com/office/drawing/2014/main" id="{8A254847-2F9F-4BBD-8C3D-61D9BA8B9F3A}"/>
               </a:ext>
             </a:extLst>
           </p:cNvPr>
@@ -10900,7 +10900,7 @@
                   <a:srgbClr val="18243C"/>
                 </a:solidFill>
               </a:rPr>
-              <a:t>Что появилось в итоговом макете</a:t>
+              <a:t>Что мы добавили в макет</a:t>
             </a:r>
           </a:p>
         </p:txBody>
@@ -10910,7 +10910,7 @@
           <p:cNvPr id="5" name="">
             <a:extLst xmlns:a="http://schemas.openxmlformats.org/drawingml/2006/main">
               <a:ext uri="{FF2B5EF4-FFF2-40B4-BE49-F238E27FC236}">
-                <a16:creationId xmlns:a16="http://schemas.microsoft.com/office/drawing/2014/main" id="{B93CCD89-257F-4F97-B3B3-8A8205CD99FC}"/>
+                <a16:creationId xmlns:a16="http://schemas.microsoft.com/office/drawing/2014/main" id="{9F7D3DDE-662D-4F69-9291-18D43388C644}"/>
               </a:ext>
             </a:extLst>
           </p:cNvPr>
@@ -11031,7 +11031,7 @@
           <p:cNvPr id="6" name="">
             <a:extLst xmlns:a="http://schemas.openxmlformats.org/drawingml/2006/main">
               <a:ext uri="{FF2B5EF4-FFF2-40B4-BE49-F238E27FC236}">
-                <a16:creationId xmlns:a16="http://schemas.microsoft.com/office/drawing/2014/main" id="{41723890-2F8E-4C40-A485-583510188BC3}"/>
+                <a16:creationId xmlns:a16="http://schemas.microsoft.com/office/drawing/2014/main" id="{37BC6E29-821C-4DA4-BA64-0118B31222E4}"/>
               </a:ext>
             </a:extLst>
           </p:cNvPr>
@@ -11152,7 +11152,7 @@
           <p:cNvPr id="7" name="">
             <a:extLst xmlns:a="http://schemas.openxmlformats.org/drawingml/2006/main">
               <a:ext uri="{FF2B5EF4-FFF2-40B4-BE49-F238E27FC236}">
-                <a16:creationId xmlns:a16="http://schemas.microsoft.com/office/drawing/2014/main" id="{90A60BDF-C60A-4F50-92CC-65CD53F2591A}"/>
+                <a16:creationId xmlns:a16="http://schemas.microsoft.com/office/drawing/2014/main" id="{1351130E-6511-455F-A871-73AFE2D66E93}"/>
               </a:ext>
             </a:extLst>
           </p:cNvPr>
@@ -11263,7 +11263,7 @@
                   <a:srgbClr val="18243C"/>
                 </a:solidFill>
               </a:rPr>
-              <a:t>Собственная навигация и вкладка статистики.</a:t>
+              <a:t>Мы сделали отдельную навигацию и вкладку статистики.</a:t>
             </a:r>
           </a:p>
         </p:txBody>
@@ -11273,7 +11273,7 @@
           <p:cNvPr id="8" name="">
             <a:extLst xmlns:a="http://schemas.openxmlformats.org/drawingml/2006/main">
               <a:ext uri="{FF2B5EF4-FFF2-40B4-BE49-F238E27FC236}">
-                <a16:creationId xmlns:a16="http://schemas.microsoft.com/office/drawing/2014/main" id="{F4750701-C545-4BF2-8A3F-55D0E27066D3}"/>
+                <a16:creationId xmlns:a16="http://schemas.microsoft.com/office/drawing/2014/main" id="{68B8BB3A-02D4-44D5-892D-EBFF84C8D9AB}"/>
               </a:ext>
             </a:extLst>
           </p:cNvPr>
@@ -11394,7 +11394,7 @@
           <p:cNvPr id="9" name="">
             <a:extLst xmlns:a="http://schemas.openxmlformats.org/drawingml/2006/main">
               <a:ext uri="{FF2B5EF4-FFF2-40B4-BE49-F238E27FC236}">
-                <a16:creationId xmlns:a16="http://schemas.microsoft.com/office/drawing/2014/main" id="{33C8D66E-9596-4544-9F56-4E433B728C69}"/>
+                <a16:creationId xmlns:a16="http://schemas.microsoft.com/office/drawing/2014/main" id="{DDC0F096-4A28-45E6-9F2B-FDCB5C6709E0}"/>
               </a:ext>
             </a:extLst>
           </p:cNvPr>
@@ -11505,7 +11505,7 @@
                   <a:srgbClr val="18243C"/>
                 </a:solidFill>
               </a:rPr>
-              <a:t>Профиль по нажатию на аватар, тема и сворачивание меню до значков.</a:t>
+              <a:t>Мы добавили вход в профиль, переключение темы и сворачивание меню.</a:t>
             </a:r>
           </a:p>
         </p:txBody>
@@ -11515,7 +11515,7 @@
           <p:cNvPr id="10" name="">
             <a:extLst xmlns:a="http://schemas.openxmlformats.org/drawingml/2006/main">
               <a:ext uri="{FF2B5EF4-FFF2-40B4-BE49-F238E27FC236}">
-                <a16:creationId xmlns:a16="http://schemas.microsoft.com/office/drawing/2014/main" id="{A8E8AE51-69D9-48FE-9F2F-F4B3F13FBD31}"/>
+                <a16:creationId xmlns:a16="http://schemas.microsoft.com/office/drawing/2014/main" id="{62BB3183-0D60-45B0-8E25-7F4658897A88}"/>
               </a:ext>
             </a:extLst>
           </p:cNvPr>
@@ -11636,7 +11636,7 @@
           <p:cNvPr id="11" name="">
             <a:extLst xmlns:a="http://schemas.openxmlformats.org/drawingml/2006/main">
               <a:ext uri="{FF2B5EF4-FFF2-40B4-BE49-F238E27FC236}">
-                <a16:creationId xmlns:a16="http://schemas.microsoft.com/office/drawing/2014/main" id="{02990063-2338-4CB0-80BC-A34A62BBD572}"/>
+                <a16:creationId xmlns:a16="http://schemas.microsoft.com/office/drawing/2014/main" id="{6A97E1CA-CB6D-4294-8DF7-97AA22763857}"/>
               </a:ext>
             </a:extLst>
           </p:cNvPr>
@@ -11747,7 +11747,7 @@
                   <a:srgbClr val="18243C"/>
                 </a:solidFill>
               </a:rPr>
-              <a:t>Карточка каждого пользователя с данными, товарами и заказами.</a:t>
+              <a:t>Мы добавили карточку пользователя с его данными, товарами и заказами.</a:t>
             </a:r>
           </a:p>
         </p:txBody>
@@ -11757,7 +11757,7 @@
           <p:cNvPr id="12" name="">
             <a:extLst xmlns:a="http://schemas.openxmlformats.org/drawingml/2006/main">
               <a:ext uri="{FF2B5EF4-FFF2-40B4-BE49-F238E27FC236}">
-                <a16:creationId xmlns:a16="http://schemas.microsoft.com/office/drawing/2014/main" id="{00557572-DA93-4667-B301-BAACF9D6C8C2}"/>
+                <a16:creationId xmlns:a16="http://schemas.microsoft.com/office/drawing/2014/main" id="{81530BB0-3573-4A39-8FFA-88506D3AD92A}"/>
               </a:ext>
             </a:extLst>
           </p:cNvPr>
@@ -11868,7 +11868,7 @@
                   <a:srgbClr val="18243C"/>
                 </a:solidFill>
               </a:rPr>
-              <a:t>Подписка в профиле обозначена как оплаченная. Цена тарифа не показана.</a:t>
+              <a:t>Мы показываем подписку в профиле как оплаченную, без цены тарифа.</a:t>
             </a:r>
           </a:p>
         </p:txBody>
@@ -11876,7 +11876,7 @@
     </p:spTree>
     <p:extLst>
       <p:ext uri="{BB962C8B-B14F-4D97-AF65-F5344CB8AC3E}">
-        <p14:creationId xmlns:p14="http://schemas.microsoft.com/office/powerpoint/2010/main" val="1594382861"/>
+        <p14:creationId xmlns:p14="http://schemas.microsoft.com/office/powerpoint/2010/main" val="1787105869"/>
       </p:ext>
     </p:extLst>
   </p:cSld>
@@ -11907,7 +11907,7 @@
           <p:cNvPr id="12" name="">
             <a:extLst xmlns:a="http://schemas.openxmlformats.org/drawingml/2006/main">
               <a:ext uri="{FF2B5EF4-FFF2-40B4-BE49-F238E27FC236}">
-                <a16:creationId xmlns:a16="http://schemas.microsoft.com/office/drawing/2014/main" id="{3A8A5412-0774-4E9D-81E6-4F335CFB78E9}"/>
+                <a16:creationId xmlns:a16="http://schemas.microsoft.com/office/drawing/2014/main" id="{6FC01298-542A-49DF-91E7-520E265DEDF1}"/>
               </a:ext>
             </a:extLst>
           </p:cNvPr>
@@ -12028,7 +12028,7 @@
           <p:cNvPr id="2" name="">
             <a:extLst xmlns:a="http://schemas.openxmlformats.org/drawingml/2006/main">
               <a:ext uri="{FF2B5EF4-FFF2-40B4-BE49-F238E27FC236}">
-                <a16:creationId xmlns:a16="http://schemas.microsoft.com/office/drawing/2014/main" id="{F8114646-11DC-443A-80B1-A10A33A8F768}"/>
+                <a16:creationId xmlns:a16="http://schemas.microsoft.com/office/drawing/2014/main" id="{F9313E53-961E-4223-B1A9-567C8AB50AC2}"/>
               </a:ext>
             </a:extLst>
           </p:cNvPr>
@@ -12149,7 +12149,7 @@
           <p:cNvPr id="3" name="">
             <a:extLst xmlns:a="http://schemas.openxmlformats.org/drawingml/2006/main">
               <a:ext uri="{FF2B5EF4-FFF2-40B4-BE49-F238E27FC236}">
-                <a16:creationId xmlns:a16="http://schemas.microsoft.com/office/drawing/2014/main" id="{4EB57662-B8D4-42A9-A0BD-0B597FF5734C}"/>
+                <a16:creationId xmlns:a16="http://schemas.microsoft.com/office/drawing/2014/main" id="{297723A1-F499-4DAE-A082-D90034303D7C}"/>
               </a:ext>
             </a:extLst>
           </p:cNvPr>
@@ -12180,7 +12180,7 @@
           <p:cNvPr id="4" name="">
             <a:extLst xmlns:a="http://schemas.openxmlformats.org/drawingml/2006/main">
               <a:ext uri="{FF2B5EF4-FFF2-40B4-BE49-F238E27FC236}">
-                <a16:creationId xmlns:a16="http://schemas.microsoft.com/office/drawing/2014/main" id="{2F02AC84-3707-49DD-BA37-875F8B9575CE}"/>
+                <a16:creationId xmlns:a16="http://schemas.microsoft.com/office/drawing/2014/main" id="{1BC43047-75E3-4D05-9BE8-F8D15EAD7EBB}"/>
               </a:ext>
             </a:extLst>
           </p:cNvPr>
@@ -12291,7 +12291,7 @@
                   <a:srgbClr val="18243C"/>
                 </a:solidFill>
               </a:rPr>
-              <a:t>Что показала проверка удобства</a:t>
+              <a:t>Что мы узнали на проверке</a:t>
             </a:r>
           </a:p>
         </p:txBody>
@@ -12301,7 +12301,7 @@
           <p:cNvPr id="5" name="">
             <a:extLst xmlns:a="http://schemas.openxmlformats.org/drawingml/2006/main">
               <a:ext uri="{FF2B5EF4-FFF2-40B4-BE49-F238E27FC236}">
-                <a16:creationId xmlns:a16="http://schemas.microsoft.com/office/drawing/2014/main" id="{F15023A6-51EA-419F-A07C-66F86E880A6B}"/>
+                <a16:creationId xmlns:a16="http://schemas.microsoft.com/office/drawing/2014/main" id="{E3BE7FF3-F2C5-4987-BBF5-807ECEFEDDD9}"/>
               </a:ext>
             </a:extLst>
           </p:cNvPr>
@@ -12422,7 +12422,7 @@
           <p:cNvPr id="6" name="">
             <a:extLst xmlns:a="http://schemas.openxmlformats.org/drawingml/2006/main">
               <a:ext uri="{FF2B5EF4-FFF2-40B4-BE49-F238E27FC236}">
-                <a16:creationId xmlns:a16="http://schemas.microsoft.com/office/drawing/2014/main" id="{8EAB28EA-F96D-4C61-BFDE-76F1488FE968}"/>
+                <a16:creationId xmlns:a16="http://schemas.microsoft.com/office/drawing/2014/main" id="{F0398AB6-0D79-4430-AFFB-9066EFB0037D}"/>
               </a:ext>
             </a:extLst>
           </p:cNvPr>
@@ -12533,7 +12533,7 @@
                   <a:srgbClr val="285BEB"/>
                 </a:solidFill>
               </a:rPr>
-              <a:t>2 участника · свободное изучение</a:t>
+              <a:t>Олег показал макет двум участникам</a:t>
             </a:r>
           </a:p>
         </p:txBody>
@@ -12543,7 +12543,7 @@
           <p:cNvPr id="7" name="">
             <a:extLst xmlns:a="http://schemas.openxmlformats.org/drawingml/2006/main">
               <a:ext uri="{FF2B5EF4-FFF2-40B4-BE49-F238E27FC236}">
-                <a16:creationId xmlns:a16="http://schemas.microsoft.com/office/drawing/2014/main" id="{15E87D93-D425-4098-B4B4-351F596FD8AC}"/>
+                <a16:creationId xmlns:a16="http://schemas.microsoft.com/office/drawing/2014/main" id="{49AFC370-8E11-4B1D-944A-BF2F6A89D6D7}"/>
               </a:ext>
             </a:extLst>
           </p:cNvPr>
@@ -12654,7 +12654,7 @@
                   <a:srgbClr val="18243C"/>
                 </a:solidFill>
               </a:rPr>
-              <a:t>Отец</a:t>
+              <a:t>Отец Олега</a:t>
             </a:r>
           </a:p>
         </p:txBody>
@@ -12664,7 +12664,7 @@
           <p:cNvPr id="8" name="">
             <a:extLst xmlns:a="http://schemas.openxmlformats.org/drawingml/2006/main">
               <a:ext uri="{FF2B5EF4-FFF2-40B4-BE49-F238E27FC236}">
-                <a16:creationId xmlns:a16="http://schemas.microsoft.com/office/drawing/2014/main" id="{8EE26290-B915-4243-975B-41ADA8D5767D}"/>
+                <a16:creationId xmlns:a16="http://schemas.microsoft.com/office/drawing/2014/main" id="{5F27951E-4033-4DAF-BEFE-77AF9334CC71}"/>
               </a:ext>
             </a:extLst>
           </p:cNvPr>
@@ -12785,7 +12785,7 @@
           <p:cNvPr id="9" name="">
             <a:extLst xmlns:a="http://schemas.openxmlformats.org/drawingml/2006/main">
               <a:ext uri="{FF2B5EF4-FFF2-40B4-BE49-F238E27FC236}">
-                <a16:creationId xmlns:a16="http://schemas.microsoft.com/office/drawing/2014/main" id="{727F7189-03DC-4FB8-989F-BB81CDD9CC23}"/>
+                <a16:creationId xmlns:a16="http://schemas.microsoft.com/office/drawing/2014/main" id="{297FD63E-1676-4D6B-B187-03B44B096D1F}"/>
               </a:ext>
             </a:extLst>
           </p:cNvPr>
@@ -12896,7 +12896,7 @@
                   <a:srgbClr val="18243C"/>
                 </a:solidFill>
               </a:rPr>
-              <a:t>Мать</a:t>
+              <a:t>Мать Олега</a:t>
             </a:r>
           </a:p>
         </p:txBody>
@@ -12906,7 +12906,7 @@
           <p:cNvPr id="10" name="">
             <a:extLst xmlns:a="http://schemas.openxmlformats.org/drawingml/2006/main">
               <a:ext uri="{FF2B5EF4-FFF2-40B4-BE49-F238E27FC236}">
-                <a16:creationId xmlns:a16="http://schemas.microsoft.com/office/drawing/2014/main" id="{2AB342D2-CDE9-4185-BAB0-F7EEFCEE72A3}"/>
+                <a16:creationId xmlns:a16="http://schemas.microsoft.com/office/drawing/2014/main" id="{2996371A-7A40-49F0-BB92-5F1C454B4CF7}"/>
               </a:ext>
             </a:extLst>
           </p:cNvPr>
@@ -13027,7 +13027,7 @@
           <p:cNvPr id="11" name="">
             <a:extLst xmlns:a="http://schemas.openxmlformats.org/drawingml/2006/main">
               <a:ext uri="{FF2B5EF4-FFF2-40B4-BE49-F238E27FC236}">
-                <a16:creationId xmlns:a16="http://schemas.microsoft.com/office/drawing/2014/main" id="{70EA494C-DBAA-449F-A8DF-0DC90BD11206}"/>
+                <a16:creationId xmlns:a16="http://schemas.microsoft.com/office/drawing/2014/main" id="{2E0DDC40-48FE-4BFC-8026-FD5F1338B078}"/>
               </a:ext>
             </a:extLst>
           </p:cNvPr>
@@ -13138,7 +13138,7 @@
                   <a:srgbClr val="18243C"/>
                 </a:solidFill>
               </a:rPr>
-              <a:t>Следующая проверка: попросить найти подписку и переключить тему без подсказки расположения кнопок.</a:t>
+              <a:t>В следующей проверке мы попросим найти подписку и переключить тему без подсказки расположения кнопок.</a:t>
             </a:r>
           </a:p>
         </p:txBody>
@@ -13146,7 +13146,7 @@
     </p:spTree>
     <p:extLst>
       <p:ext uri="{BB962C8B-B14F-4D97-AF65-F5344CB8AC3E}">
-        <p14:creationId xmlns:p14="http://schemas.microsoft.com/office/powerpoint/2010/main" val="46791049"/>
+        <p14:creationId xmlns:p14="http://schemas.microsoft.com/office/powerpoint/2010/main" val="700246771"/>
       </p:ext>
     </p:extLst>
   </p:cSld>
@@ -13177,7 +13177,7 @@
           <p:cNvPr id="11" name="">
             <a:extLst xmlns:a="http://schemas.openxmlformats.org/drawingml/2006/main">
               <a:ext uri="{FF2B5EF4-FFF2-40B4-BE49-F238E27FC236}">
-                <a16:creationId xmlns:a16="http://schemas.microsoft.com/office/drawing/2014/main" id="{7A548DF6-05E6-4B5C-832C-1D45E3D25579}"/>
+                <a16:creationId xmlns:a16="http://schemas.microsoft.com/office/drawing/2014/main" id="{97ABF1AB-A18E-4348-AD66-FDBFF9020CF6}"/>
               </a:ext>
             </a:extLst>
           </p:cNvPr>
@@ -13298,7 +13298,7 @@
           <p:cNvPr id="2" name="">
             <a:extLst xmlns:a="http://schemas.openxmlformats.org/drawingml/2006/main">
               <a:ext uri="{FF2B5EF4-FFF2-40B4-BE49-F238E27FC236}">
-                <a16:creationId xmlns:a16="http://schemas.microsoft.com/office/drawing/2014/main" id="{F6948694-F0DB-4671-825F-1273436D8463}"/>
+                <a16:creationId xmlns:a16="http://schemas.microsoft.com/office/drawing/2014/main" id="{F356ACD5-E110-4BA7-BB1F-CA41CBDE8061}"/>
               </a:ext>
             </a:extLst>
           </p:cNvPr>
@@ -13419,7 +13419,7 @@
           <p:cNvPr id="3" name="">
             <a:extLst xmlns:a="http://schemas.openxmlformats.org/drawingml/2006/main">
               <a:ext uri="{FF2B5EF4-FFF2-40B4-BE49-F238E27FC236}">
-                <a16:creationId xmlns:a16="http://schemas.microsoft.com/office/drawing/2014/main" id="{FBFEDEA9-4EB2-4EEA-85A6-78D1F6310CAA}"/>
+                <a16:creationId xmlns:a16="http://schemas.microsoft.com/office/drawing/2014/main" id="{874FCE1F-D16E-4045-B660-A3CA4BD9C0B8}"/>
               </a:ext>
             </a:extLst>
           </p:cNvPr>
@@ -13450,7 +13450,7 @@
           <p:cNvPr id="4" name="">
             <a:extLst xmlns:a="http://schemas.openxmlformats.org/drawingml/2006/main">
               <a:ext uri="{FF2B5EF4-FFF2-40B4-BE49-F238E27FC236}">
-                <a16:creationId xmlns:a16="http://schemas.microsoft.com/office/drawing/2014/main" id="{8F7E750A-6BFB-42F7-BB40-F90AA244E821}"/>
+                <a16:creationId xmlns:a16="http://schemas.microsoft.com/office/drawing/2014/main" id="{02C9469B-8589-4D37-B5C0-EDB6E68420D0}"/>
               </a:ext>
             </a:extLst>
           </p:cNvPr>
@@ -13561,7 +13561,7 @@
                   <a:srgbClr val="18243C"/>
                 </a:solidFill>
               </a:rPr>
-              <a:t>Результат и вклад команды</a:t>
+              <a:t>Как мы разделили работу</a:t>
             </a:r>
           </a:p>
         </p:txBody>
@@ -13571,7 +13571,7 @@
           <p:cNvPr id="5" name="">
             <a:extLst xmlns:a="http://schemas.openxmlformats.org/drawingml/2006/main">
               <a:ext uri="{FF2B5EF4-FFF2-40B4-BE49-F238E27FC236}">
-                <a16:creationId xmlns:a16="http://schemas.microsoft.com/office/drawing/2014/main" id="{8CBAE527-D073-4CFC-99BA-D12C9034E22C}"/>
+                <a16:creationId xmlns:a16="http://schemas.microsoft.com/office/drawing/2014/main" id="{0510CA9E-243F-4F27-BC3B-561B8F154DB2}"/>
               </a:ext>
             </a:extLst>
           </p:cNvPr>
@@ -13692,7 +13692,7 @@
           <p:cNvPr id="6" name="">
             <a:extLst xmlns:a="http://schemas.openxmlformats.org/drawingml/2006/main">
               <a:ext uri="{FF2B5EF4-FFF2-40B4-BE49-F238E27FC236}">
-                <a16:creationId xmlns:a16="http://schemas.microsoft.com/office/drawing/2014/main" id="{B528873B-26E2-47F9-8178-CA2CAB3140ED}"/>
+                <a16:creationId xmlns:a16="http://schemas.microsoft.com/office/drawing/2014/main" id="{46BC0755-502D-4C74-9ED6-28B0D36951CE}"/>
               </a:ext>
             </a:extLst>
           </p:cNvPr>
@@ -13813,7 +13813,7 @@
           <p:cNvPr id="7" name="">
             <a:extLst xmlns:a="http://schemas.openxmlformats.org/drawingml/2006/main">
               <a:ext uri="{FF2B5EF4-FFF2-40B4-BE49-F238E27FC236}">
-                <a16:creationId xmlns:a16="http://schemas.microsoft.com/office/drawing/2014/main" id="{E59F2EC4-B442-4217-A0F6-0EEB7F3CE82A}"/>
+                <a16:creationId xmlns:a16="http://schemas.microsoft.com/office/drawing/2014/main" id="{6BDB353E-E71D-4685-98D0-47C04854C908}"/>
               </a:ext>
             </a:extLst>
           </p:cNvPr>
@@ -13924,7 +13924,7 @@
                   <a:srgbClr val="18243C"/>
                 </a:solidFill>
               </a:rPr>
-              <a:t>Исходное ТЗ и основная работа над итоговым дизайном Figma. Организовал наблюдение за пользователями.</a:t>
+              <a:t>ТЗ, основная работа над итоговым дизайном Figma и проверка с пользователями.</a:t>
             </a:r>
           </a:p>
         </p:txBody>
@@ -13934,7 +13934,7 @@
           <p:cNvPr id="8" name="">
             <a:extLst xmlns:a="http://schemas.openxmlformats.org/drawingml/2006/main">
               <a:ext uri="{FF2B5EF4-FFF2-40B4-BE49-F238E27FC236}">
-                <a16:creationId xmlns:a16="http://schemas.microsoft.com/office/drawing/2014/main" id="{523D5DF9-36F5-4C15-B3EB-812F7CEF643E}"/>
+                <a16:creationId xmlns:a16="http://schemas.microsoft.com/office/drawing/2014/main" id="{A23649E3-0269-4CA2-AAC8-0652B3EA1181}"/>
               </a:ext>
             </a:extLst>
           </p:cNvPr>
@@ -14055,7 +14055,7 @@
           <p:cNvPr id="9" name="">
             <a:extLst xmlns:a="http://schemas.openxmlformats.org/drawingml/2006/main">
               <a:ext uri="{FF2B5EF4-FFF2-40B4-BE49-F238E27FC236}">
-                <a16:creationId xmlns:a16="http://schemas.microsoft.com/office/drawing/2014/main" id="{501880B5-DB0A-483A-A4D3-1EFC4420F97F}"/>
+                <a16:creationId xmlns:a16="http://schemas.microsoft.com/office/drawing/2014/main" id="{2B7C969C-8A9E-4773-89D7-91D422E50A16}"/>
               </a:ext>
             </a:extLst>
           </p:cNvPr>
@@ -14166,7 +14166,7 @@
                   <a:srgbClr val="18243C"/>
                 </a:solidFill>
               </a:rPr>
-              <a:t>Портреты пользователей, истории, UML и вайрфреймы. Участвовал в обсуждении итогового дизайна.</a:t>
+              <a:t>Портреты пользователей, истории, UML, вайрфреймы и участие в обсуждении итогового дизайна.</a:t>
             </a:r>
           </a:p>
         </p:txBody>
@@ -14176,7 +14176,7 @@
           <p:cNvPr id="10" name="">
             <a:extLst xmlns:a="http://schemas.openxmlformats.org/drawingml/2006/main">
               <a:ext uri="{FF2B5EF4-FFF2-40B4-BE49-F238E27FC236}">
-                <a16:creationId xmlns:a16="http://schemas.microsoft.com/office/drawing/2014/main" id="{6D592FEC-F50F-445D-90DF-81D3B3E58934}"/>
+                <a16:creationId xmlns:a16="http://schemas.microsoft.com/office/drawing/2014/main" id="{1BAF8A45-1654-4EE7-B182-FC0CA648F003}"/>
               </a:ext>
             </a:extLst>
           </p:cNvPr>
@@ -14287,7 +14287,7 @@
                   <a:srgbClr val="18243C"/>
                 </a:solidFill>
               </a:rPr>
-              <a:t>Все материалы и ссылки собраны в публичном репозитории DropCRM.</a:t>
+              <a:t>Мы собрали все материалы и ссылки в публичном репозитории DropCRM.</a:t>
             </a:r>
           </a:p>
         </p:txBody>
@@ -14295,7 +14295,7 @@
     </p:spTree>
     <p:extLst>
       <p:ext uri="{BB962C8B-B14F-4D97-AF65-F5344CB8AC3E}">
-        <p14:creationId xmlns:p14="http://schemas.microsoft.com/office/powerpoint/2010/main" val="945742026"/>
+        <p14:creationId xmlns:p14="http://schemas.microsoft.com/office/powerpoint/2010/main" val="1676832576"/>
       </p:ext>
     </p:extLst>
   </p:cSld>

</xml_diff>